<commit_message>
Deployed cb78fb4 with MkDocs version: 1.6.1
</commit_message>
<xml_diff>
--- a/training_materials/機械班/マシニングセンタ/img/プレゼンテーション1.pptx
+++ b/training_materials/機械班/マシニングセンタ/img/プレゼンテーション1.pptx
@@ -9,6 +9,9 @@
     <p:sldId id="258" r:id="rId3"/>
     <p:sldId id="259" r:id="rId4"/>
     <p:sldId id="260" r:id="rId5"/>
+    <p:sldId id="261" r:id="rId6"/>
+    <p:sldId id="262" r:id="rId7"/>
+    <p:sldId id="263" r:id="rId8"/>
   </p:sldIdLst>
   <p:sldSz cx="12192000" cy="6858000"/>
   <p:notesSz cx="6858000" cy="9144000"/>
@@ -4617,6 +4620,745 @@
 </p:sld>
 </file>
 
+<file path=ppt/slides/slide5.xml><?xml version="1.0" encoding="utf-8"?>
+<p:sld xmlns:a="http://schemas.openxmlformats.org/drawingml/2006/main" xmlns:r="http://schemas.openxmlformats.org/officeDocument/2006/relationships" xmlns:p="http://schemas.openxmlformats.org/presentationml/2006/main">
+  <p:cSld>
+    <p:spTree>
+      <p:nvGrpSpPr>
+        <p:cNvPr id="1" name=""/>
+        <p:cNvGrpSpPr/>
+        <p:nvPr/>
+      </p:nvGrpSpPr>
+      <p:grpSpPr>
+        <a:xfrm>
+          <a:off x="0" y="0"/>
+          <a:ext cx="0" cy="0"/>
+          <a:chOff x="0" y="0"/>
+          <a:chExt cx="0" cy="0"/>
+        </a:xfrm>
+      </p:grpSpPr>
+      <p:grpSp>
+        <p:nvGrpSpPr>
+          <p:cNvPr id="11" name="グループ化 10">
+            <a:extLst>
+              <a:ext uri="{FF2B5EF4-FFF2-40B4-BE49-F238E27FC236}">
+                <a16:creationId xmlns:a16="http://schemas.microsoft.com/office/drawing/2014/main" id="{B10B3DF9-AA17-EEE1-4A93-1FAAFF917001}"/>
+              </a:ext>
+            </a:extLst>
+          </p:cNvPr>
+          <p:cNvGrpSpPr/>
+          <p:nvPr/>
+        </p:nvGrpSpPr>
+        <p:grpSpPr>
+          <a:xfrm>
+            <a:off x="0" y="0"/>
+            <a:ext cx="10289322" cy="6858000"/>
+            <a:chOff x="0" y="0"/>
+            <a:chExt cx="10289322" cy="6858000"/>
+          </a:xfrm>
+        </p:grpSpPr>
+        <p:pic>
+          <p:nvPicPr>
+            <p:cNvPr id="5" name="図 4">
+              <a:extLst>
+                <a:ext uri="{FF2B5EF4-FFF2-40B4-BE49-F238E27FC236}">
+                  <a16:creationId xmlns:a16="http://schemas.microsoft.com/office/drawing/2014/main" id="{0FDAF4D0-7C27-F0F3-69C4-D4F5B025FC0F}"/>
+                </a:ext>
+              </a:extLst>
+            </p:cNvPr>
+            <p:cNvPicPr>
+              <a:picLocks noChangeAspect="1"/>
+            </p:cNvPicPr>
+            <p:nvPr/>
+          </p:nvPicPr>
+          <p:blipFill>
+            <a:blip r:embed="rId2">
+              <a:extLst>
+                <a:ext uri="{28A0092B-C50C-407E-A947-70E740481C1C}">
+                  <a14:useLocalDpi xmlns:a14="http://schemas.microsoft.com/office/drawing/2010/main" val="0"/>
+                </a:ext>
+              </a:extLst>
+            </a:blip>
+            <a:stretch>
+              <a:fillRect/>
+            </a:stretch>
+          </p:blipFill>
+          <p:spPr>
+            <a:xfrm>
+              <a:off x="5144661" y="0"/>
+              <a:ext cx="5144661" cy="6858000"/>
+            </a:xfrm>
+            <a:prstGeom prst="rect">
+              <a:avLst/>
+            </a:prstGeom>
+          </p:spPr>
+        </p:pic>
+        <p:pic>
+          <p:nvPicPr>
+            <p:cNvPr id="7" name="図 6">
+              <a:extLst>
+                <a:ext uri="{FF2B5EF4-FFF2-40B4-BE49-F238E27FC236}">
+                  <a16:creationId xmlns:a16="http://schemas.microsoft.com/office/drawing/2014/main" id="{94BC7D0B-59BD-8A06-76D8-303466710CCA}"/>
+                </a:ext>
+              </a:extLst>
+            </p:cNvPr>
+            <p:cNvPicPr>
+              <a:picLocks noChangeAspect="1"/>
+            </p:cNvPicPr>
+            <p:nvPr/>
+          </p:nvPicPr>
+          <p:blipFill>
+            <a:blip r:embed="rId3">
+              <a:extLst>
+                <a:ext uri="{28A0092B-C50C-407E-A947-70E740481C1C}">
+                  <a14:useLocalDpi xmlns:a14="http://schemas.microsoft.com/office/drawing/2010/main" val="0"/>
+                </a:ext>
+              </a:extLst>
+            </a:blip>
+            <a:stretch>
+              <a:fillRect/>
+            </a:stretch>
+          </p:blipFill>
+          <p:spPr>
+            <a:xfrm>
+              <a:off x="0" y="0"/>
+              <a:ext cx="5144661" cy="6858000"/>
+            </a:xfrm>
+            <a:prstGeom prst="rect">
+              <a:avLst/>
+            </a:prstGeom>
+          </p:spPr>
+        </p:pic>
+        <p:sp>
+          <p:nvSpPr>
+            <p:cNvPr id="8" name="矢印: 左カーブ 7">
+              <a:extLst>
+                <a:ext uri="{FF2B5EF4-FFF2-40B4-BE49-F238E27FC236}">
+                  <a16:creationId xmlns:a16="http://schemas.microsoft.com/office/drawing/2014/main" id="{1F901066-658A-E2F2-3276-75390FB8E2AF}"/>
+                </a:ext>
+              </a:extLst>
+            </p:cNvPr>
+            <p:cNvSpPr/>
+            <p:nvPr/>
+          </p:nvSpPr>
+          <p:spPr>
+            <a:xfrm rot="15575681">
+              <a:off x="4722926" y="-375073"/>
+              <a:ext cx="1402644" cy="4973113"/>
+            </a:xfrm>
+            <a:prstGeom prst="curvedLeftArrow">
+              <a:avLst>
+                <a:gd name="adj1" fmla="val 16652"/>
+                <a:gd name="adj2" fmla="val 46457"/>
+                <a:gd name="adj3" fmla="val 53539"/>
+              </a:avLst>
+            </a:prstGeom>
+            <a:solidFill>
+              <a:srgbClr val="FFFF00"/>
+            </a:solidFill>
+            <a:ln w="38100">
+              <a:solidFill>
+                <a:srgbClr val="FF0000"/>
+              </a:solidFill>
+            </a:ln>
+          </p:spPr>
+          <p:style>
+            <a:lnRef idx="2">
+              <a:schemeClr val="accent1">
+                <a:shade val="15000"/>
+              </a:schemeClr>
+            </a:lnRef>
+            <a:fillRef idx="1">
+              <a:schemeClr val="accent1"/>
+            </a:fillRef>
+            <a:effectRef idx="0">
+              <a:schemeClr val="accent1"/>
+            </a:effectRef>
+            <a:fontRef idx="minor">
+              <a:schemeClr val="lt1"/>
+            </a:fontRef>
+          </p:style>
+          <p:txBody>
+            <a:bodyPr rtlCol="0" anchor="ctr"/>
+            <a:lstStyle/>
+            <a:p>
+              <a:pPr algn="ctr"/>
+              <a:endParaRPr kumimoji="1" lang="ja-JP" altLang="en-US">
+                <a:solidFill>
+                  <a:schemeClr val="tx1"/>
+                </a:solidFill>
+              </a:endParaRPr>
+            </a:p>
+          </p:txBody>
+        </p:sp>
+        <p:sp>
+          <p:nvSpPr>
+            <p:cNvPr id="9" name="楕円 8">
+              <a:extLst>
+                <a:ext uri="{FF2B5EF4-FFF2-40B4-BE49-F238E27FC236}">
+                  <a16:creationId xmlns:a16="http://schemas.microsoft.com/office/drawing/2014/main" id="{9878F4E7-ECBC-22E0-5FA6-71F39CA0C301}"/>
+                </a:ext>
+              </a:extLst>
+            </p:cNvPr>
+            <p:cNvSpPr/>
+            <p:nvPr/>
+          </p:nvSpPr>
+          <p:spPr>
+            <a:xfrm>
+              <a:off x="6994937" y="2478505"/>
+              <a:ext cx="1569277" cy="914400"/>
+            </a:xfrm>
+            <a:prstGeom prst="ellipse">
+              <a:avLst/>
+            </a:prstGeom>
+            <a:noFill/>
+            <a:ln w="76200">
+              <a:solidFill>
+                <a:srgbClr val="FF0000"/>
+              </a:solidFill>
+              <a:prstDash val="dash"/>
+            </a:ln>
+          </p:spPr>
+          <p:style>
+            <a:lnRef idx="2">
+              <a:schemeClr val="accent1">
+                <a:shade val="15000"/>
+              </a:schemeClr>
+            </a:lnRef>
+            <a:fillRef idx="1">
+              <a:schemeClr val="accent1"/>
+            </a:fillRef>
+            <a:effectRef idx="0">
+              <a:schemeClr val="accent1"/>
+            </a:effectRef>
+            <a:fontRef idx="minor">
+              <a:schemeClr val="lt1"/>
+            </a:fontRef>
+          </p:style>
+          <p:txBody>
+            <a:bodyPr rtlCol="0" anchor="ctr"/>
+            <a:lstStyle/>
+            <a:p>
+              <a:pPr algn="ctr"/>
+              <a:endParaRPr kumimoji="1" lang="ja-JP" altLang="en-US"/>
+            </a:p>
+          </p:txBody>
+        </p:sp>
+        <p:sp>
+          <p:nvSpPr>
+            <p:cNvPr id="10" name="吹き出し: 円形 9">
+              <a:extLst>
+                <a:ext uri="{FF2B5EF4-FFF2-40B4-BE49-F238E27FC236}">
+                  <a16:creationId xmlns:a16="http://schemas.microsoft.com/office/drawing/2014/main" id="{03EB9CA9-16F8-B707-4F51-B753E509954C}"/>
+                </a:ext>
+              </a:extLst>
+            </p:cNvPr>
+            <p:cNvSpPr/>
+            <p:nvPr/>
+          </p:nvSpPr>
+          <p:spPr>
+            <a:xfrm>
+              <a:off x="7659259" y="1281362"/>
+              <a:ext cx="2561567" cy="1054609"/>
+            </a:xfrm>
+            <a:prstGeom prst="wedgeEllipseCallout">
+              <a:avLst>
+                <a:gd name="adj1" fmla="val -34219"/>
+                <a:gd name="adj2" fmla="val 64782"/>
+              </a:avLst>
+            </a:prstGeom>
+            <a:solidFill>
+              <a:schemeClr val="bg1"/>
+            </a:solidFill>
+            <a:ln>
+              <a:solidFill>
+                <a:schemeClr val="tx1"/>
+              </a:solidFill>
+            </a:ln>
+          </p:spPr>
+          <p:style>
+            <a:lnRef idx="2">
+              <a:schemeClr val="accent1">
+                <a:shade val="15000"/>
+              </a:schemeClr>
+            </a:lnRef>
+            <a:fillRef idx="1">
+              <a:schemeClr val="accent1"/>
+            </a:fillRef>
+            <a:effectRef idx="0">
+              <a:schemeClr val="accent1"/>
+            </a:effectRef>
+            <a:fontRef idx="minor">
+              <a:schemeClr val="lt1"/>
+            </a:fontRef>
+          </p:style>
+          <p:txBody>
+            <a:bodyPr rtlCol="0" anchor="ctr"/>
+            <a:lstStyle/>
+            <a:p>
+              <a:pPr algn="ctr"/>
+              <a:r>
+                <a:rPr kumimoji="1" lang="ja-JP" altLang="en-US" sz="2400" dirty="0">
+                  <a:solidFill>
+                    <a:srgbClr val="FF0000"/>
+                  </a:solidFill>
+                </a:rPr>
+                <a:t>良く見ると突起が</a:t>
+              </a:r>
+              <a:r>
+                <a:rPr kumimoji="1" lang="en-US" altLang="ja-JP" sz="2400" dirty="0">
+                  <a:solidFill>
+                    <a:srgbClr val="FF0000"/>
+                  </a:solidFill>
+                </a:rPr>
+                <a:t>!!!</a:t>
+              </a:r>
+              <a:endParaRPr kumimoji="1" lang="ja-JP" altLang="en-US" sz="2400" dirty="0">
+                <a:solidFill>
+                  <a:srgbClr val="FF0000"/>
+                </a:solidFill>
+              </a:endParaRPr>
+            </a:p>
+          </p:txBody>
+        </p:sp>
+      </p:grpSp>
+    </p:spTree>
+    <p:extLst>
+      <p:ext uri="{BB962C8B-B14F-4D97-AF65-F5344CB8AC3E}">
+        <p14:creationId xmlns:p14="http://schemas.microsoft.com/office/powerpoint/2010/main" val="3921619878"/>
+      </p:ext>
+    </p:extLst>
+  </p:cSld>
+  <p:clrMapOvr>
+    <a:masterClrMapping/>
+  </p:clrMapOvr>
+</p:sld>
+</file>
+
+<file path=ppt/slides/slide6.xml><?xml version="1.0" encoding="utf-8"?>
+<p:sld xmlns:a="http://schemas.openxmlformats.org/drawingml/2006/main" xmlns:r="http://schemas.openxmlformats.org/officeDocument/2006/relationships" xmlns:p="http://schemas.openxmlformats.org/presentationml/2006/main">
+  <p:cSld>
+    <p:spTree>
+      <p:nvGrpSpPr>
+        <p:cNvPr id="1" name=""/>
+        <p:cNvGrpSpPr/>
+        <p:nvPr/>
+      </p:nvGrpSpPr>
+      <p:grpSpPr>
+        <a:xfrm>
+          <a:off x="0" y="0"/>
+          <a:ext cx="0" cy="0"/>
+          <a:chOff x="0" y="0"/>
+          <a:chExt cx="0" cy="0"/>
+        </a:xfrm>
+      </p:grpSpPr>
+      <p:grpSp>
+        <p:nvGrpSpPr>
+          <p:cNvPr id="10" name="グループ化 9">
+            <a:extLst>
+              <a:ext uri="{FF2B5EF4-FFF2-40B4-BE49-F238E27FC236}">
+                <a16:creationId xmlns:a16="http://schemas.microsoft.com/office/drawing/2014/main" id="{4DFB6A16-BE58-843D-1884-94E3EFD9077A}"/>
+              </a:ext>
+            </a:extLst>
+          </p:cNvPr>
+          <p:cNvGrpSpPr/>
+          <p:nvPr/>
+        </p:nvGrpSpPr>
+        <p:grpSpPr>
+          <a:xfrm>
+            <a:off x="0" y="-1"/>
+            <a:ext cx="11800114" cy="4426042"/>
+            <a:chOff x="0" y="-1"/>
+            <a:chExt cx="11800114" cy="4426042"/>
+          </a:xfrm>
+        </p:grpSpPr>
+        <p:pic>
+          <p:nvPicPr>
+            <p:cNvPr id="5" name="図 4">
+              <a:extLst>
+                <a:ext uri="{FF2B5EF4-FFF2-40B4-BE49-F238E27FC236}">
+                  <a16:creationId xmlns:a16="http://schemas.microsoft.com/office/drawing/2014/main" id="{3DDB457C-EC1F-F37D-2C57-161344E61271}"/>
+                </a:ext>
+              </a:extLst>
+            </p:cNvPr>
+            <p:cNvPicPr>
+              <a:picLocks noChangeAspect="1"/>
+            </p:cNvPicPr>
+            <p:nvPr/>
+          </p:nvPicPr>
+          <p:blipFill>
+            <a:blip r:embed="rId2">
+              <a:extLst>
+                <a:ext uri="{28A0092B-C50C-407E-A947-70E740481C1C}">
+                  <a14:useLocalDpi xmlns:a14="http://schemas.microsoft.com/office/drawing/2010/main" val="0"/>
+                </a:ext>
+              </a:extLst>
+            </a:blip>
+            <a:stretch>
+              <a:fillRect/>
+            </a:stretch>
+          </p:blipFill>
+          <p:spPr>
+            <a:xfrm rot="5400000">
+              <a:off x="737008" y="-737008"/>
+              <a:ext cx="4426041" cy="5900057"/>
+            </a:xfrm>
+            <a:prstGeom prst="rect">
+              <a:avLst/>
+            </a:prstGeom>
+          </p:spPr>
+        </p:pic>
+        <p:pic>
+          <p:nvPicPr>
+            <p:cNvPr id="7" name="図 6">
+              <a:extLst>
+                <a:ext uri="{FF2B5EF4-FFF2-40B4-BE49-F238E27FC236}">
+                  <a16:creationId xmlns:a16="http://schemas.microsoft.com/office/drawing/2014/main" id="{9C6F6A7C-0C7D-904E-D654-14478B0B248A}"/>
+                </a:ext>
+              </a:extLst>
+            </p:cNvPr>
+            <p:cNvPicPr>
+              <a:picLocks noChangeAspect="1"/>
+            </p:cNvPicPr>
+            <p:nvPr/>
+          </p:nvPicPr>
+          <p:blipFill>
+            <a:blip r:embed="rId3">
+              <a:extLst>
+                <a:ext uri="{28A0092B-C50C-407E-A947-70E740481C1C}">
+                  <a14:useLocalDpi xmlns:a14="http://schemas.microsoft.com/office/drawing/2010/main" val="0"/>
+                </a:ext>
+              </a:extLst>
+            </a:blip>
+            <a:stretch>
+              <a:fillRect/>
+            </a:stretch>
+          </p:blipFill>
+          <p:spPr>
+            <a:xfrm>
+              <a:off x="5900057" y="-1"/>
+              <a:ext cx="5900057" cy="4426041"/>
+            </a:xfrm>
+            <a:prstGeom prst="rect">
+              <a:avLst/>
+            </a:prstGeom>
+          </p:spPr>
+        </p:pic>
+      </p:grpSp>
+    </p:spTree>
+    <p:extLst>
+      <p:ext uri="{BB962C8B-B14F-4D97-AF65-F5344CB8AC3E}">
+        <p14:creationId xmlns:p14="http://schemas.microsoft.com/office/powerpoint/2010/main" val="2334416276"/>
+      </p:ext>
+    </p:extLst>
+  </p:cSld>
+  <p:clrMapOvr>
+    <a:masterClrMapping/>
+  </p:clrMapOvr>
+</p:sld>
+</file>
+
+<file path=ppt/slides/slide7.xml><?xml version="1.0" encoding="utf-8"?>
+<p:sld xmlns:a="http://schemas.openxmlformats.org/drawingml/2006/main" xmlns:r="http://schemas.openxmlformats.org/officeDocument/2006/relationships" xmlns:p="http://schemas.openxmlformats.org/presentationml/2006/main">
+  <p:cSld>
+    <p:spTree>
+      <p:nvGrpSpPr>
+        <p:cNvPr id="1" name=""/>
+        <p:cNvGrpSpPr/>
+        <p:nvPr/>
+      </p:nvGrpSpPr>
+      <p:grpSpPr>
+        <a:xfrm>
+          <a:off x="0" y="0"/>
+          <a:ext cx="0" cy="0"/>
+          <a:chOff x="0" y="0"/>
+          <a:chExt cx="0" cy="0"/>
+        </a:xfrm>
+      </p:grpSpPr>
+      <p:grpSp>
+        <p:nvGrpSpPr>
+          <p:cNvPr id="12" name="グループ化 11">
+            <a:extLst>
+              <a:ext uri="{FF2B5EF4-FFF2-40B4-BE49-F238E27FC236}">
+                <a16:creationId xmlns:a16="http://schemas.microsoft.com/office/drawing/2014/main" id="{7428E7E0-C524-A3B4-FFD9-7B763FA8ADD0}"/>
+              </a:ext>
+            </a:extLst>
+          </p:cNvPr>
+          <p:cNvGrpSpPr/>
+          <p:nvPr/>
+        </p:nvGrpSpPr>
+        <p:grpSpPr>
+          <a:xfrm>
+            <a:off x="0" y="0"/>
+            <a:ext cx="10289043" cy="4895779"/>
+            <a:chOff x="0" y="0"/>
+            <a:chExt cx="10289043" cy="4895779"/>
+          </a:xfrm>
+        </p:grpSpPr>
+        <p:pic>
+          <p:nvPicPr>
+            <p:cNvPr id="5" name="図 4">
+              <a:extLst>
+                <a:ext uri="{FF2B5EF4-FFF2-40B4-BE49-F238E27FC236}">
+                  <a16:creationId xmlns:a16="http://schemas.microsoft.com/office/drawing/2014/main" id="{1B03A92E-3785-CC78-C21E-10A0C2748088}"/>
+                </a:ext>
+              </a:extLst>
+            </p:cNvPr>
+            <p:cNvPicPr>
+              <a:picLocks noChangeAspect="1"/>
+            </p:cNvPicPr>
+            <p:nvPr/>
+          </p:nvPicPr>
+          <p:blipFill>
+            <a:blip r:embed="rId2">
+              <a:extLst>
+                <a:ext uri="{28A0092B-C50C-407E-A947-70E740481C1C}">
+                  <a14:useLocalDpi xmlns:a14="http://schemas.microsoft.com/office/drawing/2010/main" val="0"/>
+                </a:ext>
+              </a:extLst>
+            </a:blip>
+            <a:srcRect l="12348" r="15823" b="7284"/>
+            <a:stretch>
+              <a:fillRect/>
+            </a:stretch>
+          </p:blipFill>
+          <p:spPr>
+            <a:xfrm>
+              <a:off x="0" y="0"/>
+              <a:ext cx="4579257" cy="4434114"/>
+            </a:xfrm>
+            <a:prstGeom prst="rect">
+              <a:avLst/>
+            </a:prstGeom>
+          </p:spPr>
+        </p:pic>
+        <p:pic>
+          <p:nvPicPr>
+            <p:cNvPr id="7" name="図 6">
+              <a:extLst>
+                <a:ext uri="{FF2B5EF4-FFF2-40B4-BE49-F238E27FC236}">
+                  <a16:creationId xmlns:a16="http://schemas.microsoft.com/office/drawing/2014/main" id="{8B5FC927-EC10-FD1C-410B-01B9BE892B6A}"/>
+                </a:ext>
+              </a:extLst>
+            </p:cNvPr>
+            <p:cNvPicPr>
+              <a:picLocks noChangeAspect="1"/>
+            </p:cNvPicPr>
+            <p:nvPr/>
+          </p:nvPicPr>
+          <p:blipFill>
+            <a:blip r:embed="rId3">
+              <a:extLst>
+                <a:ext uri="{28A0092B-C50C-407E-A947-70E740481C1C}">
+                  <a14:useLocalDpi xmlns:a14="http://schemas.microsoft.com/office/drawing/2010/main" val="0"/>
+                </a:ext>
+              </a:extLst>
+            </a:blip>
+            <a:srcRect l="4329" b="959"/>
+            <a:stretch>
+              <a:fillRect/>
+            </a:stretch>
+          </p:blipFill>
+          <p:spPr>
+            <a:xfrm>
+              <a:off x="4579257" y="0"/>
+              <a:ext cx="5709786" cy="4434114"/>
+            </a:xfrm>
+            <a:prstGeom prst="rect">
+              <a:avLst/>
+            </a:prstGeom>
+          </p:spPr>
+        </p:pic>
+        <p:sp>
+          <p:nvSpPr>
+            <p:cNvPr id="8" name="テキスト ボックス 7">
+              <a:extLst>
+                <a:ext uri="{FF2B5EF4-FFF2-40B4-BE49-F238E27FC236}">
+                  <a16:creationId xmlns:a16="http://schemas.microsoft.com/office/drawing/2014/main" id="{D4CD8F03-981D-F086-4444-AA9BAC1BC16F}"/>
+                </a:ext>
+              </a:extLst>
+            </p:cNvPr>
+            <p:cNvSpPr txBox="1"/>
+            <p:nvPr/>
+          </p:nvSpPr>
+          <p:spPr>
+            <a:xfrm>
+              <a:off x="196748" y="4434114"/>
+              <a:ext cx="4185761" cy="461665"/>
+            </a:xfrm>
+            <a:prstGeom prst="rect">
+              <a:avLst/>
+            </a:prstGeom>
+            <a:noFill/>
+          </p:spPr>
+          <p:txBody>
+            <a:bodyPr wrap="none" rtlCol="0">
+              <a:spAutoFit/>
+            </a:bodyPr>
+            <a:lstStyle/>
+            <a:p>
+              <a:r>
+                <a:rPr kumimoji="1" lang="ja-JP" altLang="en-US" sz="2400" dirty="0"/>
+                <a:t>きちんとはまっていない状態</a:t>
+              </a:r>
+            </a:p>
+          </p:txBody>
+        </p:sp>
+        <p:sp>
+          <p:nvSpPr>
+            <p:cNvPr id="9" name="テキスト ボックス 8">
+              <a:extLst>
+                <a:ext uri="{FF2B5EF4-FFF2-40B4-BE49-F238E27FC236}">
+                  <a16:creationId xmlns:a16="http://schemas.microsoft.com/office/drawing/2014/main" id="{8D6C928F-4D81-0E23-35B6-E825CDA674AF}"/>
+                </a:ext>
+              </a:extLst>
+            </p:cNvPr>
+            <p:cNvSpPr txBox="1"/>
+            <p:nvPr/>
+          </p:nvSpPr>
+          <p:spPr>
+            <a:xfrm>
+              <a:off x="6572375" y="4416807"/>
+              <a:ext cx="1723549" cy="461665"/>
+            </a:xfrm>
+            <a:prstGeom prst="rect">
+              <a:avLst/>
+            </a:prstGeom>
+            <a:noFill/>
+          </p:spPr>
+          <p:txBody>
+            <a:bodyPr wrap="none" rtlCol="0">
+              <a:spAutoFit/>
+            </a:bodyPr>
+            <a:lstStyle/>
+            <a:p>
+              <a:r>
+                <a:rPr kumimoji="1" lang="ja-JP" altLang="en-US" sz="2400" dirty="0"/>
+                <a:t>正常な状態</a:t>
+              </a:r>
+            </a:p>
+          </p:txBody>
+        </p:sp>
+        <p:sp>
+          <p:nvSpPr>
+            <p:cNvPr id="10" name="楕円 9">
+              <a:extLst>
+                <a:ext uri="{FF2B5EF4-FFF2-40B4-BE49-F238E27FC236}">
+                  <a16:creationId xmlns:a16="http://schemas.microsoft.com/office/drawing/2014/main" id="{8D37A58C-2B8D-C768-5521-85AD3B2D904A}"/>
+                </a:ext>
+              </a:extLst>
+            </p:cNvPr>
+            <p:cNvSpPr/>
+            <p:nvPr/>
+          </p:nvSpPr>
+          <p:spPr>
+            <a:xfrm>
+              <a:off x="1624651" y="1313542"/>
+              <a:ext cx="762949" cy="1480457"/>
+            </a:xfrm>
+            <a:prstGeom prst="ellipse">
+              <a:avLst/>
+            </a:prstGeom>
+            <a:noFill/>
+            <a:ln w="76200">
+              <a:solidFill>
+                <a:srgbClr val="FF0000"/>
+              </a:solidFill>
+              <a:prstDash val="dash"/>
+            </a:ln>
+          </p:spPr>
+          <p:style>
+            <a:lnRef idx="2">
+              <a:schemeClr val="accent1">
+                <a:shade val="15000"/>
+              </a:schemeClr>
+            </a:lnRef>
+            <a:fillRef idx="1">
+              <a:schemeClr val="accent1"/>
+            </a:fillRef>
+            <a:effectRef idx="0">
+              <a:schemeClr val="accent1"/>
+            </a:effectRef>
+            <a:fontRef idx="minor">
+              <a:schemeClr val="lt1"/>
+            </a:fontRef>
+          </p:style>
+          <p:txBody>
+            <a:bodyPr rtlCol="0" anchor="ctr"/>
+            <a:lstStyle/>
+            <a:p>
+              <a:pPr algn="ctr"/>
+              <a:endParaRPr kumimoji="1" lang="ja-JP" altLang="en-US"/>
+            </a:p>
+          </p:txBody>
+        </p:sp>
+        <p:sp>
+          <p:nvSpPr>
+            <p:cNvPr id="11" name="楕円 10">
+              <a:extLst>
+                <a:ext uri="{FF2B5EF4-FFF2-40B4-BE49-F238E27FC236}">
+                  <a16:creationId xmlns:a16="http://schemas.microsoft.com/office/drawing/2014/main" id="{B190210E-4776-B9D7-F68A-1A31F1577F14}"/>
+                </a:ext>
+              </a:extLst>
+            </p:cNvPr>
+            <p:cNvSpPr/>
+            <p:nvPr/>
+          </p:nvSpPr>
+          <p:spPr>
+            <a:xfrm>
+              <a:off x="6857051" y="1320798"/>
+              <a:ext cx="879064" cy="1473201"/>
+            </a:xfrm>
+            <a:prstGeom prst="ellipse">
+              <a:avLst/>
+            </a:prstGeom>
+            <a:noFill/>
+            <a:ln w="76200">
+              <a:solidFill>
+                <a:srgbClr val="FF0000"/>
+              </a:solidFill>
+              <a:prstDash val="dash"/>
+            </a:ln>
+          </p:spPr>
+          <p:style>
+            <a:lnRef idx="2">
+              <a:schemeClr val="accent1">
+                <a:shade val="15000"/>
+              </a:schemeClr>
+            </a:lnRef>
+            <a:fillRef idx="1">
+              <a:schemeClr val="accent1"/>
+            </a:fillRef>
+            <a:effectRef idx="0">
+              <a:schemeClr val="accent1"/>
+            </a:effectRef>
+            <a:fontRef idx="minor">
+              <a:schemeClr val="lt1"/>
+            </a:fontRef>
+          </p:style>
+          <p:txBody>
+            <a:bodyPr rtlCol="0" anchor="ctr"/>
+            <a:lstStyle/>
+            <a:p>
+              <a:pPr algn="ctr"/>
+              <a:endParaRPr kumimoji="1" lang="ja-JP" altLang="en-US"/>
+            </a:p>
+          </p:txBody>
+        </p:sp>
+      </p:grpSp>
+    </p:spTree>
+    <p:extLst>
+      <p:ext uri="{BB962C8B-B14F-4D97-AF65-F5344CB8AC3E}">
+        <p14:creationId xmlns:p14="http://schemas.microsoft.com/office/powerpoint/2010/main" val="2864448554"/>
+      </p:ext>
+    </p:extLst>
+  </p:cSld>
+  <p:clrMapOvr>
+    <a:masterClrMapping/>
+  </p:clrMapOvr>
+</p:sld>
+</file>
+
 <file path=ppt/theme/theme1.xml><?xml version="1.0" encoding="utf-8"?>
 <a:theme xmlns:a="http://schemas.openxmlformats.org/drawingml/2006/main" name="Office テーマ">
   <a:themeElements>

</xml_diff>